<commit_message>
PPT slide 13: budget updated to student jugaad build (Rs.5k-9k)
</commit_message>
<xml_diff>
--- a/presentation/ASTRA-MINE_SUDARSHAN.pptx
+++ b/presentation/ASTRA-MINE_SUDARSHAN.pptx
@@ -9046,7 +9046,7 @@
                 </a:solidFill>
                 <a:latin typeface="Segoe UI"/>
               </a:rPr>
-              <a:t>BUDGET (REALISTIC, STUDENT-SCALE)</a:t>
+              <a:t>BUDGET — STUDENT JUGAAD BUILD</a:t>
             </a:r>
           </a:p>
         </p:txBody>
@@ -9077,11 +9077,11 @@
             <a:r>
               <a:rPr sz="4400" b="1" i="0">
                 <a:solidFill>
-                  <a:srgbClr val="FFFFFF"/>
-                </a:solidFill>
-                <a:latin typeface="Segoe UI"/>
-              </a:rPr>
-              <a:t>₹35k – ₹50k</a:t>
+                  <a:srgbClr val="3DDC84"/>
+                </a:solidFill>
+                <a:latin typeface="Segoe UI"/>
+              </a:rPr>
+              <a:t>₹5k – ₹9k</a:t>
             </a:r>
           </a:p>
         </p:txBody>
@@ -9116,7 +9116,7 @@
                 </a:solidFill>
                 <a:latin typeface="Segoe UI"/>
               </a:rPr>
-              <a:t>recommended build  ·  ₹20k–30k minimum viable</a:t>
+              <a:t>same science  ·  ~20% of the ₹35k–50k recommended build</a:t>
             </a:r>
           </a:p>
         </p:txBody>
@@ -9129,8 +9129,8 @@
         </p:nvSpPr>
         <p:spPr>
           <a:xfrm>
-            <a:off x="777240" y="3493008"/>
-            <a:ext cx="2377440" cy="310896"/>
+            <a:off x="777240" y="3419856"/>
+            <a:ext cx="2834640" cy="310896"/>
           </a:xfrm>
           <a:prstGeom prst="roundRect">
             <a:avLst>
@@ -9177,8 +9177,8 @@
         </p:nvSpPr>
         <p:spPr>
           <a:xfrm>
-            <a:off x="777240" y="3506724"/>
-            <a:ext cx="2377440" cy="310896"/>
+            <a:off x="777240" y="3433572"/>
+            <a:ext cx="2834640" cy="310896"/>
           </a:xfrm>
           <a:prstGeom prst="rect">
             <a:avLst/>
@@ -9199,7 +9199,7 @@
                 </a:solidFill>
                 <a:latin typeface="Segoe UI"/>
               </a:rPr>
-              <a:t>Mobility (chassis, motors, wheels, driver)</a:t>
+              <a:t>Brain: Pi Zero 2 W or ESP32-CAM + laptop</a:t>
             </a:r>
           </a:p>
         </p:txBody>
@@ -9212,8 +9212,8 @@
         </p:nvSpPr>
         <p:spPr>
           <a:xfrm>
-            <a:off x="777240" y="3895344"/>
-            <a:ext cx="1828800" cy="310896"/>
+            <a:off x="777240" y="3785616"/>
+            <a:ext cx="2377440" cy="310896"/>
           </a:xfrm>
           <a:prstGeom prst="roundRect">
             <a:avLst>
@@ -9260,8 +9260,8 @@
         </p:nvSpPr>
         <p:spPr>
           <a:xfrm>
-            <a:off x="777240" y="3909059"/>
-            <a:ext cx="1828800" cy="310896"/>
+            <a:off x="777240" y="3799332"/>
+            <a:ext cx="2377440" cy="310896"/>
           </a:xfrm>
           <a:prstGeom prst="rect">
             <a:avLst/>
@@ -9282,7 +9282,7 @@
                 </a:solidFill>
                 <a:latin typeface="Segoe UI"/>
               </a:rPr>
-              <a:t>Power (3S pack, BMS, buck)</a:t>
+              <a:t>BO motors + DIY plywood chassis</a:t>
             </a:r>
           </a:p>
         </p:txBody>
@@ -9295,8 +9295,8 @@
         </p:nvSpPr>
         <p:spPr>
           <a:xfrm>
-            <a:off x="777240" y="4297680"/>
-            <a:ext cx="2103120" cy="310896"/>
+            <a:off x="777240" y="4151376"/>
+            <a:ext cx="2011680" cy="310896"/>
           </a:xfrm>
           <a:prstGeom prst="roundRect">
             <a:avLst>
@@ -9343,8 +9343,8 @@
         </p:nvSpPr>
         <p:spPr>
           <a:xfrm>
-            <a:off x="777240" y="4311396"/>
-            <a:ext cx="2103120" cy="310896"/>
+            <a:off x="777240" y="4165092"/>
+            <a:ext cx="2011680" cy="310896"/>
           </a:xfrm>
           <a:prstGeom prst="rect">
             <a:avLst/>
@@ -9365,7 +9365,7 @@
                 </a:solidFill>
                 <a:latin typeface="Segoe UI"/>
               </a:rPr>
-              <a:t>Brain (Pi 5 kit + camera)</a:t>
+              <a:t>Printed-paper encoder discs</a:t>
             </a:r>
           </a:p>
         </p:txBody>
@@ -9378,7 +9378,7 @@
         </p:nvSpPr>
         <p:spPr>
           <a:xfrm>
-            <a:off x="777240" y="4700016"/>
+            <a:off x="777240" y="4517136"/>
             <a:ext cx="2194560" cy="310896"/>
           </a:xfrm>
           <a:prstGeom prst="roundRect">
@@ -9426,7 +9426,7 @@
         </p:nvSpPr>
         <p:spPr>
           <a:xfrm>
-            <a:off x="777240" y="4713732"/>
+            <a:off x="777240" y="4530852"/>
             <a:ext cx="2194560" cy="310896"/>
           </a:xfrm>
           <a:prstGeom prst="rect">
@@ -9448,7 +9448,7 @@
                 </a:solidFill>
                 <a:latin typeface="Segoe UI"/>
               </a:rPr>
-              <a:t>Sensors (IMU, INA219, ToF, encoders)</a:t>
+              <a:t>UPS battery + BMS (reclaimed)</a:t>
             </a:r>
           </a:p>
         </p:txBody>
@@ -9461,8 +9461,8 @@
         </p:nvSpPr>
         <p:spPr>
           <a:xfrm>
-            <a:off x="777240" y="5102352"/>
-            <a:ext cx="2011680" cy="310896"/>
+            <a:off x="777240" y="4882896"/>
+            <a:ext cx="1920240" cy="310896"/>
           </a:xfrm>
           <a:prstGeom prst="roundRect">
             <a:avLst>
@@ -9509,8 +9509,8 @@
         </p:nvSpPr>
         <p:spPr>
           <a:xfrm>
-            <a:off x="777240" y="5116068"/>
-            <a:ext cx="2011680" cy="310896"/>
+            <a:off x="777240" y="4896612"/>
+            <a:ext cx="1920240" cy="310896"/>
           </a:xfrm>
           <a:prstGeom prst="rect">
             <a:avLst/>
@@ -9531,64 +9531,25 @@
                 </a:solidFill>
                 <a:latin typeface="Segoe UI"/>
               </a:rPr>
-              <a:t>Station node + scoop + testbed</a:t>
-            </a:r>
-          </a:p>
-        </p:txBody>
-      </p:sp>
-      <p:sp>
-        <p:nvSpPr>
-          <p:cNvPr id="21" name="TextBox 20"/>
-          <p:cNvSpPr txBox="1"/>
-          <p:nvPr/>
-        </p:nvSpPr>
-        <p:spPr>
-          <a:xfrm>
-            <a:off x="777240" y="5559552"/>
-            <a:ext cx="4434840" cy="365760"/>
-          </a:xfrm>
-          <a:prstGeom prst="rect">
-            <a:avLst/>
-          </a:prstGeom>
-          <a:noFill/>
-        </p:spPr>
-        <p:txBody>
-          <a:bodyPr wrap="square" lIns="0" rIns="0" tIns="0" bIns="0" anchor="t">
-            <a:spAutoFit/>
-          </a:bodyPr>
-          <a:lstStyle/>
-          <a:p>
-            <a:pPr algn="l">
-              <a:lnSpc>
-                <a:spcPct val="105000"/>
-              </a:lnSpc>
-            </a:pPr>
-            <a:r>
-              <a:rPr sz="1050" b="0" i="0">
-                <a:solidFill>
-                  <a:srgbClr val="6D82AD"/>
-                </a:solidFill>
-                <a:latin typeface="Segoe UI"/>
-              </a:rPr>
-              <a:t>No LiDAR, no lab-grade simulant — scope discipline is the budget strategy.</a:t>
-            </a:r>
-          </a:p>
-        </p:txBody>
-      </p:sp>
-      <p:sp>
-        <p:nvSpPr>
-          <p:cNvPr id="22" name="Rounded Rectangle 21"/>
+              <a:t>HC-SR04 / bump detection</a:t>
+            </a:r>
+          </a:p>
+        </p:txBody>
+      </p:sp>
+      <p:sp>
+        <p:nvSpPr>
+          <p:cNvPr id="21" name="Rounded Rectangle 20"/>
           <p:cNvSpPr/>
           <p:nvPr/>
         </p:nvSpPr>
         <p:spPr>
           <a:xfrm>
-            <a:off x="5715000" y="1572768"/>
-            <a:ext cx="5971032" cy="960120"/>
+            <a:off x="777240" y="5248656"/>
+            <a:ext cx="2286000" cy="310896"/>
           </a:xfrm>
           <a:prstGeom prst="roundRect">
             <a:avLst>
-              <a:gd name="adj" fmla="val 5500"/>
+              <a:gd name="adj" fmla="val 50000"/>
             </a:avLst>
           </a:prstGeom>
           <a:solidFill>
@@ -9625,118 +9586,87 @@
       </p:sp>
       <p:sp>
         <p:nvSpPr>
+          <p:cNvPr id="22" name="TextBox 21"/>
+          <p:cNvSpPr txBox="1"/>
+          <p:nvPr/>
+        </p:nvSpPr>
+        <p:spPr>
+          <a:xfrm>
+            <a:off x="777240" y="5262372"/>
+            <a:ext cx="2286000" cy="310896"/>
+          </a:xfrm>
+          <a:prstGeom prst="rect">
+            <a:avLst/>
+          </a:prstGeom>
+          <a:noFill/>
+        </p:spPr>
+        <p:txBody>
+          <a:bodyPr wrap="square" lIns="0" rIns="0" tIns="0" bIns="0" anchor="ctr">
+            <a:spAutoFit/>
+          </a:bodyPr>
+          <a:lstStyle/>
+          <a:p>
+            <a:pPr algn="ctr"/>
+            <a:r>
+              <a:rPr sz="950" b="1" i="0">
+                <a:solidFill>
+                  <a:srgbClr val="D8E4FF"/>
+                </a:solidFill>
+                <a:latin typeface="Segoe UI"/>
+              </a:rPr>
+              <a:t>Kitchen scale + tarpaulin testbed</a:t>
+            </a:r>
+          </a:p>
+        </p:txBody>
+      </p:sp>
+      <p:sp>
+        <p:nvSpPr>
           <p:cNvPr id="23" name="TextBox 22"/>
           <p:cNvSpPr txBox="1"/>
           <p:nvPr/>
         </p:nvSpPr>
         <p:spPr>
           <a:xfrm>
-            <a:off x="5971032" y="1700784"/>
-            <a:ext cx="2743200" cy="292608"/>
-          </a:xfrm>
-          <a:prstGeom prst="rect">
-            <a:avLst/>
-          </a:prstGeom>
-          <a:noFill/>
-        </p:spPr>
-        <p:txBody>
-          <a:bodyPr wrap="square" lIns="0" rIns="0" tIns="0" bIns="0" anchor="t">
-            <a:spAutoFit/>
-          </a:bodyPr>
-          <a:lstStyle/>
-          <a:p>
-            <a:pPr algn="l"/>
-            <a:r>
-              <a:rPr sz="1500" b="1" i="0">
-                <a:solidFill>
-                  <a:srgbClr val="FFFFFF"/>
-                </a:solidFill>
-                <a:latin typeface="Segoe UI"/>
-              </a:rPr>
-              <a:t>Shreyas Deraje</a:t>
-            </a:r>
-          </a:p>
-        </p:txBody>
-      </p:sp>
-      <p:sp>
-        <p:nvSpPr>
-          <p:cNvPr id="24" name="TextBox 23"/>
-          <p:cNvSpPr txBox="1"/>
-          <p:nvPr/>
-        </p:nvSpPr>
-        <p:spPr>
-          <a:xfrm>
-            <a:off x="5971032" y="2029967"/>
-            <a:ext cx="5440680" cy="274320"/>
-          </a:xfrm>
-          <a:prstGeom prst="rect">
-            <a:avLst/>
-          </a:prstGeom>
-          <a:noFill/>
-        </p:spPr>
-        <p:txBody>
-          <a:bodyPr wrap="square" lIns="0" rIns="0" tIns="0" bIns="0" anchor="t">
-            <a:spAutoFit/>
-          </a:bodyPr>
-          <a:lstStyle/>
-          <a:p>
-            <a:pPr algn="l"/>
-            <a:r>
-              <a:rPr sz="1000" b="1" i="0">
+            <a:off x="777240" y="5632704"/>
+            <a:ext cx="4434840" cy="365760"/>
+          </a:xfrm>
+          <a:prstGeom prst="rect">
+            <a:avLst/>
+          </a:prstGeom>
+          <a:noFill/>
+        </p:spPr>
+        <p:txBody>
+          <a:bodyPr wrap="square" lIns="0" rIns="0" tIns="0" bIns="0" anchor="t">
+            <a:spAutoFit/>
+          </a:bodyPr>
+          <a:lstStyle/>
+          <a:p>
+            <a:pPr algn="l">
+              <a:lnSpc>
+                <a:spcPct val="105000"/>
+              </a:lnSpc>
+            </a:pPr>
+            <a:r>
+              <a:rPr sz="1050" b="0" i="1">
                 <a:solidFill>
                   <a:srgbClr val="FFB03A"/>
                 </a:solidFill>
                 <a:latin typeface="Segoe UI"/>
               </a:rPr>
-              <a:t>TEAM LEAD · AI &amp; SYSTEM ARCHITECTURE</a:t>
-            </a:r>
-          </a:p>
-        </p:txBody>
-      </p:sp>
-      <p:sp>
-        <p:nvSpPr>
-          <p:cNvPr id="25" name="TextBox 24"/>
-          <p:cNvSpPr txBox="1"/>
-          <p:nvPr/>
-        </p:nvSpPr>
-        <p:spPr>
-          <a:xfrm>
-            <a:off x="5971032" y="2267712"/>
-            <a:ext cx="5440680" cy="256032"/>
-          </a:xfrm>
-          <a:prstGeom prst="rect">
-            <a:avLst/>
-          </a:prstGeom>
-          <a:noFill/>
-        </p:spPr>
-        <p:txBody>
-          <a:bodyPr wrap="square" lIns="0" rIns="0" tIns="0" bIns="0" anchor="t">
-            <a:spAutoFit/>
-          </a:bodyPr>
-          <a:lstStyle/>
-          <a:p>
-            <a:pPr algn="l"/>
-            <a:r>
-              <a:rPr sz="1050" b="0" i="0">
-                <a:solidFill>
-                  <a:srgbClr val="6D82AD"/>
-                </a:solidFill>
-                <a:latin typeface="Segoe UI"/>
-              </a:rPr>
-              <a:t>mission optimizer, perception, integration, research lead</a:t>
-            </a:r>
-          </a:p>
-        </p:txBody>
-      </p:sp>
-      <p:sp>
-        <p:nvSpPr>
-          <p:cNvPr id="26" name="Rounded Rectangle 25"/>
+              <a:t>Frugal engineering is real space engineering — Mangalyaan cost less than a movie about Mars.</a:t>
+            </a:r>
+          </a:p>
+        </p:txBody>
+      </p:sp>
+      <p:sp>
+        <p:nvSpPr>
+          <p:cNvPr id="24" name="Rounded Rectangle 23"/>
           <p:cNvSpPr/>
           <p:nvPr/>
         </p:nvSpPr>
         <p:spPr>
           <a:xfrm>
-            <a:off x="5715000" y="2642615"/>
+            <a:off x="5715000" y="1572768"/>
             <a:ext cx="5971032" cy="960120"/>
           </a:xfrm>
           <a:prstGeom prst="roundRect">
@@ -9778,14 +9708,84 @@
       </p:sp>
       <p:sp>
         <p:nvSpPr>
+          <p:cNvPr id="25" name="TextBox 24"/>
+          <p:cNvSpPr txBox="1"/>
+          <p:nvPr/>
+        </p:nvSpPr>
+        <p:spPr>
+          <a:xfrm>
+            <a:off x="5971032" y="1700784"/>
+            <a:ext cx="2743200" cy="292608"/>
+          </a:xfrm>
+          <a:prstGeom prst="rect">
+            <a:avLst/>
+          </a:prstGeom>
+          <a:noFill/>
+        </p:spPr>
+        <p:txBody>
+          <a:bodyPr wrap="square" lIns="0" rIns="0" tIns="0" bIns="0" anchor="t">
+            <a:spAutoFit/>
+          </a:bodyPr>
+          <a:lstStyle/>
+          <a:p>
+            <a:pPr algn="l"/>
+            <a:r>
+              <a:rPr sz="1500" b="1" i="0">
+                <a:solidFill>
+                  <a:srgbClr val="FFFFFF"/>
+                </a:solidFill>
+                <a:latin typeface="Segoe UI"/>
+              </a:rPr>
+              <a:t>Shreyas Deraje</a:t>
+            </a:r>
+          </a:p>
+        </p:txBody>
+      </p:sp>
+      <p:sp>
+        <p:nvSpPr>
+          <p:cNvPr id="26" name="TextBox 25"/>
+          <p:cNvSpPr txBox="1"/>
+          <p:nvPr/>
+        </p:nvSpPr>
+        <p:spPr>
+          <a:xfrm>
+            <a:off x="5971032" y="2029967"/>
+            <a:ext cx="5440680" cy="274320"/>
+          </a:xfrm>
+          <a:prstGeom prst="rect">
+            <a:avLst/>
+          </a:prstGeom>
+          <a:noFill/>
+        </p:spPr>
+        <p:txBody>
+          <a:bodyPr wrap="square" lIns="0" rIns="0" tIns="0" bIns="0" anchor="t">
+            <a:spAutoFit/>
+          </a:bodyPr>
+          <a:lstStyle/>
+          <a:p>
+            <a:pPr algn="l"/>
+            <a:r>
+              <a:rPr sz="1000" b="1" i="0">
+                <a:solidFill>
+                  <a:srgbClr val="FFB03A"/>
+                </a:solidFill>
+                <a:latin typeface="Segoe UI"/>
+              </a:rPr>
+              <a:t>TEAM LEAD · AI &amp; SYSTEM ARCHITECTURE</a:t>
+            </a:r>
+          </a:p>
+        </p:txBody>
+      </p:sp>
+      <p:sp>
+        <p:nvSpPr>
           <p:cNvPr id="27" name="TextBox 26"/>
           <p:cNvSpPr txBox="1"/>
           <p:nvPr/>
         </p:nvSpPr>
         <p:spPr>
           <a:xfrm>
-            <a:off x="5971032" y="2770632"/>
-            <a:ext cx="2743200" cy="292608"/>
+            <a:off x="5971032" y="2267712"/>
+            <a:ext cx="5440680" cy="256032"/>
           </a:xfrm>
           <a:prstGeom prst="rect">
             <a:avLst/>
@@ -9800,96 +9800,26 @@
           <a:p>
             <a:pPr algn="l"/>
             <a:r>
-              <a:rPr sz="1500" b="1" i="0">
-                <a:solidFill>
-                  <a:srgbClr val="FFFFFF"/>
-                </a:solidFill>
-                <a:latin typeface="Segoe UI"/>
-              </a:rPr>
-              <a:t>Pruthviraj Anchan</a:t>
-            </a:r>
-          </a:p>
-        </p:txBody>
-      </p:sp>
-      <p:sp>
-        <p:nvSpPr>
-          <p:cNvPr id="28" name="TextBox 27"/>
-          <p:cNvSpPr txBox="1"/>
-          <p:nvPr/>
-        </p:nvSpPr>
-        <p:spPr>
-          <a:xfrm>
-            <a:off x="5971032" y="3099815"/>
-            <a:ext cx="5440680" cy="274320"/>
-          </a:xfrm>
-          <a:prstGeom prst="rect">
-            <a:avLst/>
-          </a:prstGeom>
-          <a:noFill/>
-        </p:spPr>
-        <p:txBody>
-          <a:bodyPr wrap="square" lIns="0" rIns="0" tIns="0" bIns="0" anchor="t">
-            <a:spAutoFit/>
-          </a:bodyPr>
-          <a:lstStyle/>
-          <a:p>
-            <a:pPr algn="l"/>
-            <a:r>
-              <a:rPr sz="1000" b="1" i="0">
-                <a:solidFill>
-                  <a:srgbClr val="29D3FF"/>
-                </a:solidFill>
-                <a:latin typeface="Segoe UI"/>
-              </a:rPr>
-              <a:t>ROBOTICS &amp; MECHANISMS</a:t>
-            </a:r>
-          </a:p>
-        </p:txBody>
-      </p:sp>
-      <p:sp>
-        <p:nvSpPr>
-          <p:cNvPr id="29" name="TextBox 28"/>
-          <p:cNvSpPr txBox="1"/>
-          <p:nvPr/>
-        </p:nvSpPr>
-        <p:spPr>
-          <a:xfrm>
-            <a:off x="5971032" y="3337559"/>
-            <a:ext cx="5440680" cy="256032"/>
-          </a:xfrm>
-          <a:prstGeom prst="rect">
-            <a:avLst/>
-          </a:prstGeom>
-          <a:noFill/>
-        </p:spPr>
-        <p:txBody>
-          <a:bodyPr wrap="square" lIns="0" rIns="0" tIns="0" bIns="0" anchor="t">
-            <a:spAutoFit/>
-          </a:bodyPr>
-          <a:lstStyle/>
-          <a:p>
-            <a:pPr algn="l"/>
-            <a:r>
               <a:rPr sz="1050" b="0" i="0">
                 <a:solidFill>
                   <a:srgbClr val="6D82AD"/>
                 </a:solidFill>
                 <a:latin typeface="Segoe UI"/>
               </a:rPr>
-              <a:t>chassis, drivetrain, scoop design, testbed construction</a:t>
-            </a:r>
-          </a:p>
-        </p:txBody>
-      </p:sp>
-      <p:sp>
-        <p:nvSpPr>
-          <p:cNvPr id="30" name="Rounded Rectangle 29"/>
+              <a:t>mission optimizer, perception, integration, research lead</a:t>
+            </a:r>
+          </a:p>
+        </p:txBody>
+      </p:sp>
+      <p:sp>
+        <p:nvSpPr>
+          <p:cNvPr id="28" name="Rounded Rectangle 27"/>
           <p:cNvSpPr/>
           <p:nvPr/>
         </p:nvSpPr>
         <p:spPr>
           <a:xfrm>
-            <a:off x="5715000" y="3712463"/>
+            <a:off x="5715000" y="2642615"/>
             <a:ext cx="5971032" cy="960120"/>
           </a:xfrm>
           <a:prstGeom prst="roundRect">
@@ -9931,14 +9861,84 @@
       </p:sp>
       <p:sp>
         <p:nvSpPr>
+          <p:cNvPr id="29" name="TextBox 28"/>
+          <p:cNvSpPr txBox="1"/>
+          <p:nvPr/>
+        </p:nvSpPr>
+        <p:spPr>
+          <a:xfrm>
+            <a:off x="5971032" y="2770632"/>
+            <a:ext cx="2743200" cy="292608"/>
+          </a:xfrm>
+          <a:prstGeom prst="rect">
+            <a:avLst/>
+          </a:prstGeom>
+          <a:noFill/>
+        </p:spPr>
+        <p:txBody>
+          <a:bodyPr wrap="square" lIns="0" rIns="0" tIns="0" bIns="0" anchor="t">
+            <a:spAutoFit/>
+          </a:bodyPr>
+          <a:lstStyle/>
+          <a:p>
+            <a:pPr algn="l"/>
+            <a:r>
+              <a:rPr sz="1500" b="1" i="0">
+                <a:solidFill>
+                  <a:srgbClr val="FFFFFF"/>
+                </a:solidFill>
+                <a:latin typeface="Segoe UI"/>
+              </a:rPr>
+              <a:t>Pruthviraj Anchan</a:t>
+            </a:r>
+          </a:p>
+        </p:txBody>
+      </p:sp>
+      <p:sp>
+        <p:nvSpPr>
+          <p:cNvPr id="30" name="TextBox 29"/>
+          <p:cNvSpPr txBox="1"/>
+          <p:nvPr/>
+        </p:nvSpPr>
+        <p:spPr>
+          <a:xfrm>
+            <a:off x="5971032" y="3099815"/>
+            <a:ext cx="5440680" cy="274320"/>
+          </a:xfrm>
+          <a:prstGeom prst="rect">
+            <a:avLst/>
+          </a:prstGeom>
+          <a:noFill/>
+        </p:spPr>
+        <p:txBody>
+          <a:bodyPr wrap="square" lIns="0" rIns="0" tIns="0" bIns="0" anchor="t">
+            <a:spAutoFit/>
+          </a:bodyPr>
+          <a:lstStyle/>
+          <a:p>
+            <a:pPr algn="l"/>
+            <a:r>
+              <a:rPr sz="1000" b="1" i="0">
+                <a:solidFill>
+                  <a:srgbClr val="29D3FF"/>
+                </a:solidFill>
+                <a:latin typeface="Segoe UI"/>
+              </a:rPr>
+              <a:t>ROBOTICS &amp; MECHANISMS</a:t>
+            </a:r>
+          </a:p>
+        </p:txBody>
+      </p:sp>
+      <p:sp>
+        <p:nvSpPr>
           <p:cNvPr id="31" name="TextBox 30"/>
           <p:cNvSpPr txBox="1"/>
           <p:nvPr/>
         </p:nvSpPr>
         <p:spPr>
           <a:xfrm>
-            <a:off x="5971032" y="3840479"/>
-            <a:ext cx="2743200" cy="292608"/>
+            <a:off x="5971032" y="3337559"/>
+            <a:ext cx="5440680" cy="256032"/>
           </a:xfrm>
           <a:prstGeom prst="rect">
             <a:avLst/>
@@ -9953,96 +9953,26 @@
           <a:p>
             <a:pPr algn="l"/>
             <a:r>
-              <a:rPr sz="1500" b="1" i="0">
-                <a:solidFill>
-                  <a:srgbClr val="FFFFFF"/>
-                </a:solidFill>
-                <a:latin typeface="Segoe UI"/>
-              </a:rPr>
-              <a:t>Puneeth</a:t>
-            </a:r>
-          </a:p>
-        </p:txBody>
-      </p:sp>
-      <p:sp>
-        <p:nvSpPr>
-          <p:cNvPr id="32" name="TextBox 31"/>
-          <p:cNvSpPr txBox="1"/>
-          <p:nvPr/>
-        </p:nvSpPr>
-        <p:spPr>
-          <a:xfrm>
-            <a:off x="5971032" y="4169663"/>
-            <a:ext cx="5440680" cy="274320"/>
-          </a:xfrm>
-          <a:prstGeom prst="rect">
-            <a:avLst/>
-          </a:prstGeom>
-          <a:noFill/>
-        </p:spPr>
-        <p:txBody>
-          <a:bodyPr wrap="square" lIns="0" rIns="0" tIns="0" bIns="0" anchor="t">
-            <a:spAutoFit/>
-          </a:bodyPr>
-          <a:lstStyle/>
-          <a:p>
-            <a:pPr algn="l"/>
-            <a:r>
-              <a:rPr sz="1000" b="1" i="0">
-                <a:solidFill>
-                  <a:srgbClr val="29D3FF"/>
-                </a:solidFill>
-                <a:latin typeface="Segoe UI"/>
-              </a:rPr>
-              <a:t>EMBEDDED &amp; POWER</a:t>
-            </a:r>
-          </a:p>
-        </p:txBody>
-      </p:sp>
-      <p:sp>
-        <p:nvSpPr>
-          <p:cNvPr id="33" name="TextBox 32"/>
-          <p:cNvSpPr txBox="1"/>
-          <p:nvPr/>
-        </p:nvSpPr>
-        <p:spPr>
-          <a:xfrm>
-            <a:off x="5971032" y="4407407"/>
-            <a:ext cx="5440680" cy="256032"/>
-          </a:xfrm>
-          <a:prstGeom prst="rect">
-            <a:avLst/>
-          </a:prstGeom>
-          <a:noFill/>
-        </p:spPr>
-        <p:txBody>
-          <a:bodyPr wrap="square" lIns="0" rIns="0" tIns="0" bIns="0" anchor="t">
-            <a:spAutoFit/>
-          </a:bodyPr>
-          <a:lstStyle/>
-          <a:p>
-            <a:pPr algn="l"/>
-            <a:r>
               <a:rPr sz="1050" b="0" i="0">
                 <a:solidFill>
                   <a:srgbClr val="6D82AD"/>
                 </a:solidFill>
                 <a:latin typeface="Segoe UI"/>
               </a:rPr>
-              <a:t>ESP32 firmware, wiring, battery system, sensor bring-up</a:t>
-            </a:r>
-          </a:p>
-        </p:txBody>
-      </p:sp>
-      <p:sp>
-        <p:nvSpPr>
-          <p:cNvPr id="34" name="Rounded Rectangle 33"/>
+              <a:t>chassis, drivetrain, scoop design, testbed construction</a:t>
+            </a:r>
+          </a:p>
+        </p:txBody>
+      </p:sp>
+      <p:sp>
+        <p:nvSpPr>
+          <p:cNvPr id="32" name="Rounded Rectangle 31"/>
           <p:cNvSpPr/>
           <p:nvPr/>
         </p:nvSpPr>
         <p:spPr>
           <a:xfrm>
-            <a:off x="5715000" y="4782312"/>
+            <a:off x="5715000" y="3712463"/>
             <a:ext cx="5971032" cy="960120"/>
           </a:xfrm>
           <a:prstGeom prst="roundRect">
@@ -10084,7 +10014,160 @@
       </p:sp>
       <p:sp>
         <p:nvSpPr>
+          <p:cNvPr id="33" name="TextBox 32"/>
+          <p:cNvSpPr txBox="1"/>
+          <p:nvPr/>
+        </p:nvSpPr>
+        <p:spPr>
+          <a:xfrm>
+            <a:off x="5971032" y="3840479"/>
+            <a:ext cx="2743200" cy="292608"/>
+          </a:xfrm>
+          <a:prstGeom prst="rect">
+            <a:avLst/>
+          </a:prstGeom>
+          <a:noFill/>
+        </p:spPr>
+        <p:txBody>
+          <a:bodyPr wrap="square" lIns="0" rIns="0" tIns="0" bIns="0" anchor="t">
+            <a:spAutoFit/>
+          </a:bodyPr>
+          <a:lstStyle/>
+          <a:p>
+            <a:pPr algn="l"/>
+            <a:r>
+              <a:rPr sz="1500" b="1" i="0">
+                <a:solidFill>
+                  <a:srgbClr val="FFFFFF"/>
+                </a:solidFill>
+                <a:latin typeface="Segoe UI"/>
+              </a:rPr>
+              <a:t>Puneeth</a:t>
+            </a:r>
+          </a:p>
+        </p:txBody>
+      </p:sp>
+      <p:sp>
+        <p:nvSpPr>
+          <p:cNvPr id="34" name="TextBox 33"/>
+          <p:cNvSpPr txBox="1"/>
+          <p:nvPr/>
+        </p:nvSpPr>
+        <p:spPr>
+          <a:xfrm>
+            <a:off x="5971032" y="4169663"/>
+            <a:ext cx="5440680" cy="274320"/>
+          </a:xfrm>
+          <a:prstGeom prst="rect">
+            <a:avLst/>
+          </a:prstGeom>
+          <a:noFill/>
+        </p:spPr>
+        <p:txBody>
+          <a:bodyPr wrap="square" lIns="0" rIns="0" tIns="0" bIns="0" anchor="t">
+            <a:spAutoFit/>
+          </a:bodyPr>
+          <a:lstStyle/>
+          <a:p>
+            <a:pPr algn="l"/>
+            <a:r>
+              <a:rPr sz="1000" b="1" i="0">
+                <a:solidFill>
+                  <a:srgbClr val="29D3FF"/>
+                </a:solidFill>
+                <a:latin typeface="Segoe UI"/>
+              </a:rPr>
+              <a:t>EMBEDDED &amp; POWER</a:t>
+            </a:r>
+          </a:p>
+        </p:txBody>
+      </p:sp>
+      <p:sp>
+        <p:nvSpPr>
           <p:cNvPr id="35" name="TextBox 34"/>
+          <p:cNvSpPr txBox="1"/>
+          <p:nvPr/>
+        </p:nvSpPr>
+        <p:spPr>
+          <a:xfrm>
+            <a:off x="5971032" y="4407407"/>
+            <a:ext cx="5440680" cy="256032"/>
+          </a:xfrm>
+          <a:prstGeom prst="rect">
+            <a:avLst/>
+          </a:prstGeom>
+          <a:noFill/>
+        </p:spPr>
+        <p:txBody>
+          <a:bodyPr wrap="square" lIns="0" rIns="0" tIns="0" bIns="0" anchor="t">
+            <a:spAutoFit/>
+          </a:bodyPr>
+          <a:lstStyle/>
+          <a:p>
+            <a:pPr algn="l"/>
+            <a:r>
+              <a:rPr sz="1050" b="0" i="0">
+                <a:solidFill>
+                  <a:srgbClr val="6D82AD"/>
+                </a:solidFill>
+                <a:latin typeface="Segoe UI"/>
+              </a:rPr>
+              <a:t>ESP32 firmware, wiring, battery system, sensor bring-up</a:t>
+            </a:r>
+          </a:p>
+        </p:txBody>
+      </p:sp>
+      <p:sp>
+        <p:nvSpPr>
+          <p:cNvPr id="36" name="Rounded Rectangle 35"/>
+          <p:cNvSpPr/>
+          <p:nvPr/>
+        </p:nvSpPr>
+        <p:spPr>
+          <a:xfrm>
+            <a:off x="5715000" y="4782312"/>
+            <a:ext cx="5971032" cy="960120"/>
+          </a:xfrm>
+          <a:prstGeom prst="roundRect">
+            <a:avLst>
+              <a:gd name="adj" fmla="val 5500"/>
+            </a:avLst>
+          </a:prstGeom>
+          <a:solidFill>
+            <a:srgbClr val="0D1730"/>
+          </a:solidFill>
+          <a:ln w="9525">
+            <a:solidFill>
+              <a:srgbClr val="1D2C4D"/>
+            </a:solidFill>
+          </a:ln>
+          <a:effectLst/>
+        </p:spPr>
+        <p:style>
+          <a:lnRef idx="1">
+            <a:schemeClr val="accent1"/>
+          </a:lnRef>
+          <a:fillRef idx="3">
+            <a:schemeClr val="accent1"/>
+          </a:fillRef>
+          <a:effectRef idx="2">
+            <a:schemeClr val="accent1"/>
+          </a:effectRef>
+          <a:fontRef idx="minor">
+            <a:schemeClr val="lt1"/>
+          </a:fontRef>
+        </p:style>
+        <p:txBody>
+          <a:bodyPr rtlCol="0" anchor="ctr"/>
+          <a:lstStyle/>
+          <a:p>
+            <a:pPr algn="ctr"/>
+          </a:p>
+        </p:txBody>
+      </p:sp>
+      <p:sp>
+        <p:nvSpPr>
+          <p:cNvPr id="37" name="TextBox 36"/>
           <p:cNvSpPr txBox="1"/>
           <p:nvPr/>
         </p:nvSpPr>
@@ -10119,7 +10202,7 @@
       </p:sp>
       <p:sp>
         <p:nvSpPr>
-          <p:cNvPr id="36" name="TextBox 35"/>
+          <p:cNvPr id="38" name="TextBox 37"/>
           <p:cNvSpPr txBox="1"/>
           <p:nvPr/>
         </p:nvSpPr>
@@ -10154,7 +10237,7 @@
       </p:sp>
       <p:sp>
         <p:nvSpPr>
-          <p:cNvPr id="37" name="TextBox 36"/>
+          <p:cNvPr id="39" name="TextBox 38"/>
           <p:cNvSpPr txBox="1"/>
           <p:nvPr/>
         </p:nvSpPr>

</xml_diff>